<commit_message>
docs: fix the repo name in the presentation (ee-mortgate -> ee-mortgage)
</commit_message>
<xml_diff>
--- a/docs/Apresentacao_FunctionalTesting_Project1_UTFPR.pptx
+++ b/docs/Apresentacao_FunctionalTesting_Project1_UTFPR.pptx
@@ -12218,7 +12218,7 @@
                 <a:cs typeface="Calibri"/>
                 <a:sym typeface="Calibri"/>
               </a:rPr>
-              <a:t>JANERI FILHO, Osvaldo; KLOSOWSKI JUNIOR, Marcos. ee-mortgate: Mortgage Testing Lab. Repositório de código.  Disponível em: https://github.com/ojaneri/ee-mortgate. 2026.</a:t>
+              <a:t>JANERI FILHO, Osvaldo; KLOSOWSKI JUNIOR, Marcos. ee-mortgage: Mortgage Testing Lab. Repositório de código.  Disponível em: https://github.com/ojaneri/ee-mortgage. 2026.</a:t>
             </a:r>
             <a:endParaRPr/>
           </a:p>
@@ -15305,7 +15305,7 @@
                 <a:cs typeface="Arial"/>
                 <a:sym typeface="Arial"/>
               </a:rPr>
-              <a:t>github.com/ojaneri/ee-mortgate</a:t>
+              <a:t>github.com/ojaneri/ee-mortgage</a:t>
             </a:r>
             <a:r>
               <a:rPr lang="en-US" sz="2000">

</xml_diff>